<commit_message>
chore: remove outdated PowerPoint presentation template and update existing template for improved visual consistency
</commit_message>
<xml_diff>
--- a/docs/docs/files/GC-F-004FormatoPlantillaPresentacionPowerPointV09 (2).pptx
+++ b/docs/docs/files/GC-F-004FormatoPlantillaPresentacionPowerPointV09 (2).pptx
@@ -5,10 +5,10 @@
     <p:sldMasterId id="2147483648" r:id="rId1"/>
   </p:sldMasterIdLst>
   <p:notesMasterIdLst>
-    <p:notesMasterId r:id="rId20"/>
+    <p:notesMasterId r:id="rId17"/>
   </p:notesMasterIdLst>
   <p:handoutMasterIdLst>
-    <p:handoutMasterId r:id="rId21"/>
+    <p:handoutMasterId r:id="rId18"/>
   </p:handoutMasterIdLst>
   <p:sldIdLst>
     <p:sldId id="541" r:id="rId2"/>
@@ -20,15 +20,12 @@
     <p:sldId id="537" r:id="rId8"/>
     <p:sldId id="557" r:id="rId9"/>
     <p:sldId id="545" r:id="rId10"/>
-    <p:sldId id="556" r:id="rId11"/>
-    <p:sldId id="566" r:id="rId12"/>
-    <p:sldId id="567" r:id="rId13"/>
-    <p:sldId id="550" r:id="rId14"/>
-    <p:sldId id="552" r:id="rId15"/>
-    <p:sldId id="558" r:id="rId16"/>
-    <p:sldId id="532" r:id="rId17"/>
-    <p:sldId id="544" r:id="rId18"/>
-    <p:sldId id="531" r:id="rId19"/>
+    <p:sldId id="566" r:id="rId11"/>
+    <p:sldId id="567" r:id="rId12"/>
+    <p:sldId id="550" r:id="rId13"/>
+    <p:sldId id="552" r:id="rId14"/>
+    <p:sldId id="558" r:id="rId15"/>
+    <p:sldId id="531" r:id="rId16"/>
   </p:sldIdLst>
   <p:sldSz cx="12192000" cy="6858000"/>
   <p:notesSz cx="6858000" cy="9144000"/>
@@ -422,27 +419,6 @@
 </p188:cmLst>
 </file>
 
-<file path=ppt/comments/modernComment_22C_2461712B.xml><?xml version="1.0" encoding="utf-8"?>
-<p188:cmLst xmlns:a="http://schemas.openxmlformats.org/drawingml/2006/main" xmlns:r="http://schemas.openxmlformats.org/officeDocument/2006/relationships" xmlns:p188="http://schemas.microsoft.com/office/powerpoint/2018/8/main">
-  <p188:cm id="{28F456A8-017C-44BB-B0DA-251F321016DF}" authorId="{27DD254F-37CE-B72A-D929-E70B54B0ED62}" created="2025-05-09T17:23:09.288">
-    <pc:sldMkLst xmlns:pc="http://schemas.microsoft.com/office/powerpoint/2013/main/command">
-      <pc:docMk/>
-      <pc:sldMk cId="244571600" sldId="554"/>
-    </pc:sldMkLst>
-    <p188:txBody>
-      <a:bodyPr/>
-      <a:lstStyle/>
-      <a:p>
-        <a:r>
-          <a:rPr lang="en-US"/>
-          <a:t>2</a:t>
-        </a:r>
-      </a:p>
-    </p188:txBody>
-  </p188:cm>
-</p188:cmLst>
-</file>
-
 <file path=ppt/comments/modernComment_22D_3032A30.xml><?xml version="1.0" encoding="utf-8"?>
 <p188:cmLst xmlns:a="http://schemas.openxmlformats.org/drawingml/2006/main" xmlns:r="http://schemas.openxmlformats.org/officeDocument/2006/relationships" xmlns:p188="http://schemas.microsoft.com/office/powerpoint/2018/8/main">
   <p188:cm id="{13417762-9219-4DAF-B33E-5393D017C703}" authorId="{27DD254F-37CE-B72A-D929-E70B54B0ED62}" created="2025-05-09T17:21:40.691">
@@ -4898,410 +4874,6 @@
 <file path=ppt/slides/slide10.xml><?xml version="1.0" encoding="utf-8"?>
 <p:sld xmlns:a="http://schemas.openxmlformats.org/drawingml/2006/main" xmlns:r="http://schemas.openxmlformats.org/officeDocument/2006/relationships" xmlns:p="http://schemas.openxmlformats.org/presentationml/2006/main">
   <p:cSld>
-    <p:bg>
-      <p:bgPr>
-        <a:blipFill dpi="0" rotWithShape="1">
-          <a:blip r:embed="rId3">
-            <a:lum/>
-          </a:blip>
-          <a:srcRect/>
-          <a:stretch>
-            <a:fillRect/>
-          </a:stretch>
-        </a:blipFill>
-        <a:effectLst/>
-      </p:bgPr>
-    </p:bg>
-    <p:spTree>
-      <p:nvGrpSpPr>
-        <p:cNvPr id="1" name="">
-          <a:extLst>
-            <a:ext uri="{FF2B5EF4-FFF2-40B4-BE49-F238E27FC236}">
-              <a16:creationId xmlns:a16="http://schemas.microsoft.com/office/drawing/2014/main" id="{395BB55E-A0AF-120D-3F1C-74CBA3C04F3C}"/>
-            </a:ext>
-          </a:extLst>
-        </p:cNvPr>
-        <p:cNvGrpSpPr/>
-        <p:nvPr/>
-      </p:nvGrpSpPr>
-      <p:grpSpPr>
-        <a:xfrm>
-          <a:off x="0" y="0"/>
-          <a:ext cx="0" cy="0"/>
-          <a:chOff x="0" y="0"/>
-          <a:chExt cx="0" cy="0"/>
-        </a:xfrm>
-      </p:grpSpPr>
-      <p:sp>
-        <p:nvSpPr>
-          <p:cNvPr id="8" name="CuadroTexto 4">
-            <a:extLst>
-              <a:ext uri="{FF2B5EF4-FFF2-40B4-BE49-F238E27FC236}">
-                <a16:creationId xmlns:a16="http://schemas.microsoft.com/office/drawing/2014/main" id="{026FB49B-4FA2-5E79-0CA6-756242526103}"/>
-              </a:ext>
-            </a:extLst>
-          </p:cNvPr>
-          <p:cNvSpPr txBox="1"/>
-          <p:nvPr/>
-        </p:nvSpPr>
-        <p:spPr>
-          <a:xfrm>
-            <a:off x="995422" y="2551837"/>
-            <a:ext cx="6453678" cy="923330"/>
-          </a:xfrm>
-          <a:prstGeom prst="rect">
-            <a:avLst/>
-          </a:prstGeom>
-          <a:noFill/>
-        </p:spPr>
-        <p:txBody>
-          <a:bodyPr wrap="square" lIns="91440" tIns="45720" rIns="91440" bIns="45720" rtlCol="0" anchor="t">
-            <a:spAutoFit/>
-          </a:bodyPr>
-          <a:lstStyle>
-            <a:defPPr>
-              <a:defRPr lang="es-CO"/>
-            </a:defPPr>
-            <a:lvl1pPr marL="0" algn="l" defTabSz="914400" rtl="0" eaLnBrk="1" latinLnBrk="0" hangingPunct="1">
-              <a:defRPr sz="1800" kern="1200">
-                <a:solidFill>
-                  <a:schemeClr val="tx1"/>
-                </a:solidFill>
-                <a:latin typeface="+mn-lt"/>
-                <a:ea typeface="+mn-ea"/>
-                <a:cs typeface="+mn-cs"/>
-              </a:defRPr>
-            </a:lvl1pPr>
-            <a:lvl2pPr marL="457200" algn="l" defTabSz="914400" rtl="0" eaLnBrk="1" latinLnBrk="0" hangingPunct="1">
-              <a:defRPr sz="1800" kern="1200">
-                <a:solidFill>
-                  <a:schemeClr val="tx1"/>
-                </a:solidFill>
-                <a:latin typeface="+mn-lt"/>
-                <a:ea typeface="+mn-ea"/>
-                <a:cs typeface="+mn-cs"/>
-              </a:defRPr>
-            </a:lvl2pPr>
-            <a:lvl3pPr marL="914400" algn="l" defTabSz="914400" rtl="0" eaLnBrk="1" latinLnBrk="0" hangingPunct="1">
-              <a:defRPr sz="1800" kern="1200">
-                <a:solidFill>
-                  <a:schemeClr val="tx1"/>
-                </a:solidFill>
-                <a:latin typeface="+mn-lt"/>
-                <a:ea typeface="+mn-ea"/>
-                <a:cs typeface="+mn-cs"/>
-              </a:defRPr>
-            </a:lvl3pPr>
-            <a:lvl4pPr marL="1371600" algn="l" defTabSz="914400" rtl="0" eaLnBrk="1" latinLnBrk="0" hangingPunct="1">
-              <a:defRPr sz="1800" kern="1200">
-                <a:solidFill>
-                  <a:schemeClr val="tx1"/>
-                </a:solidFill>
-                <a:latin typeface="+mn-lt"/>
-                <a:ea typeface="+mn-ea"/>
-                <a:cs typeface="+mn-cs"/>
-              </a:defRPr>
-            </a:lvl4pPr>
-            <a:lvl5pPr marL="1828800" algn="l" defTabSz="914400" rtl="0" eaLnBrk="1" latinLnBrk="0" hangingPunct="1">
-              <a:defRPr sz="1800" kern="1200">
-                <a:solidFill>
-                  <a:schemeClr val="tx1"/>
-                </a:solidFill>
-                <a:latin typeface="+mn-lt"/>
-                <a:ea typeface="+mn-ea"/>
-                <a:cs typeface="+mn-cs"/>
-              </a:defRPr>
-            </a:lvl5pPr>
-            <a:lvl6pPr marL="2286000" algn="l" defTabSz="914400" rtl="0" eaLnBrk="1" latinLnBrk="0" hangingPunct="1">
-              <a:defRPr sz="1800" kern="1200">
-                <a:solidFill>
-                  <a:schemeClr val="tx1"/>
-                </a:solidFill>
-                <a:latin typeface="+mn-lt"/>
-                <a:ea typeface="+mn-ea"/>
-                <a:cs typeface="+mn-cs"/>
-              </a:defRPr>
-            </a:lvl6pPr>
-            <a:lvl7pPr marL="2743200" algn="l" defTabSz="914400" rtl="0" eaLnBrk="1" latinLnBrk="0" hangingPunct="1">
-              <a:defRPr sz="1800" kern="1200">
-                <a:solidFill>
-                  <a:schemeClr val="tx1"/>
-                </a:solidFill>
-                <a:latin typeface="+mn-lt"/>
-                <a:ea typeface="+mn-ea"/>
-                <a:cs typeface="+mn-cs"/>
-              </a:defRPr>
-            </a:lvl7pPr>
-            <a:lvl8pPr marL="3200400" algn="l" defTabSz="914400" rtl="0" eaLnBrk="1" latinLnBrk="0" hangingPunct="1">
-              <a:defRPr sz="1800" kern="1200">
-                <a:solidFill>
-                  <a:schemeClr val="tx1"/>
-                </a:solidFill>
-                <a:latin typeface="+mn-lt"/>
-                <a:ea typeface="+mn-ea"/>
-                <a:cs typeface="+mn-cs"/>
-              </a:defRPr>
-            </a:lvl8pPr>
-            <a:lvl9pPr marL="3657600" algn="l" defTabSz="914400" rtl="0" eaLnBrk="1" latinLnBrk="0" hangingPunct="1">
-              <a:defRPr sz="1800" kern="1200">
-                <a:solidFill>
-                  <a:schemeClr val="tx1"/>
-                </a:solidFill>
-                <a:latin typeface="+mn-lt"/>
-                <a:ea typeface="+mn-ea"/>
-                <a:cs typeface="+mn-cs"/>
-              </a:defRPr>
-            </a:lvl9pPr>
-          </a:lstStyle>
-          <a:p>
-            <a:pPr marL="0" marR="0" lvl="0" indent="0" algn="l" defTabSz="914400" rtl="0" eaLnBrk="1" fontAlgn="auto" latinLnBrk="0" hangingPunct="1">
-              <a:lnSpc>
-                <a:spcPct val="100000"/>
-              </a:lnSpc>
-              <a:spcBef>
-                <a:spcPts val="0"/>
-              </a:spcBef>
-              <a:spcAft>
-                <a:spcPts val="0"/>
-              </a:spcAft>
-              <a:buClrTx/>
-              <a:buSzTx/>
-              <a:buFontTx/>
-              <a:buNone/>
-              <a:tabLst/>
-              <a:defRPr/>
-            </a:pPr>
-            <a:r>
-              <a:rPr lang="es-ES" sz="5400" b="1" dirty="0">
-                <a:solidFill>
-                  <a:prstClr val="black">
-                    <a:lumMod val="75000"/>
-                    <a:lumOff val="25000"/>
-                  </a:prstClr>
-                </a:solidFill>
-                <a:latin typeface="Work Sans Bold Roman"/>
-              </a:rPr>
-              <a:t>Metodología</a:t>
-            </a:r>
-          </a:p>
-        </p:txBody>
-      </p:sp>
-      <p:sp>
-        <p:nvSpPr>
-          <p:cNvPr id="9" name="CuadroTexto 7">
-            <a:extLst>
-              <a:ext uri="{FF2B5EF4-FFF2-40B4-BE49-F238E27FC236}">
-                <a16:creationId xmlns:a16="http://schemas.microsoft.com/office/drawing/2014/main" id="{2A5B7BAF-923C-71D0-8EC3-E1FF9DD03EE7}"/>
-              </a:ext>
-            </a:extLst>
-          </p:cNvPr>
-          <p:cNvSpPr txBox="1"/>
-          <p:nvPr/>
-        </p:nvSpPr>
-        <p:spPr>
-          <a:xfrm>
-            <a:off x="991243" y="3469376"/>
-            <a:ext cx="10093711" cy="1015663"/>
-          </a:xfrm>
-          <a:prstGeom prst="rect">
-            <a:avLst/>
-          </a:prstGeom>
-          <a:noFill/>
-        </p:spPr>
-        <p:txBody>
-          <a:bodyPr rot="0" spcFirstLastPara="0" vert="horz" wrap="square" lIns="91440" tIns="45720" rIns="91440" bIns="45720" numCol="1" spcCol="0" rtlCol="0" fromWordArt="0" anchor="t" anchorCtr="0" forceAA="0" compatLnSpc="1">
-            <a:prstTxWarp prst="textNoShape">
-              <a:avLst/>
-            </a:prstTxWarp>
-            <a:spAutoFit/>
-          </a:bodyPr>
-          <a:lstStyle>
-            <a:defPPr>
-              <a:defRPr lang="es-CO"/>
-            </a:defPPr>
-            <a:lvl1pPr marL="0" algn="l" defTabSz="914400" rtl="0" eaLnBrk="1" latinLnBrk="0" hangingPunct="1">
-              <a:defRPr sz="1800" kern="1200">
-                <a:solidFill>
-                  <a:schemeClr val="tx1"/>
-                </a:solidFill>
-                <a:latin typeface="+mn-lt"/>
-                <a:ea typeface="+mn-ea"/>
-                <a:cs typeface="+mn-cs"/>
-              </a:defRPr>
-            </a:lvl1pPr>
-            <a:lvl2pPr marL="457200" algn="l" defTabSz="914400" rtl="0" eaLnBrk="1" latinLnBrk="0" hangingPunct="1">
-              <a:defRPr sz="1800" kern="1200">
-                <a:solidFill>
-                  <a:schemeClr val="tx1"/>
-                </a:solidFill>
-                <a:latin typeface="+mn-lt"/>
-                <a:ea typeface="+mn-ea"/>
-                <a:cs typeface="+mn-cs"/>
-              </a:defRPr>
-            </a:lvl2pPr>
-            <a:lvl3pPr marL="914400" algn="l" defTabSz="914400" rtl="0" eaLnBrk="1" latinLnBrk="0" hangingPunct="1">
-              <a:defRPr sz="1800" kern="1200">
-                <a:solidFill>
-                  <a:schemeClr val="tx1"/>
-                </a:solidFill>
-                <a:latin typeface="+mn-lt"/>
-                <a:ea typeface="+mn-ea"/>
-                <a:cs typeface="+mn-cs"/>
-              </a:defRPr>
-            </a:lvl3pPr>
-            <a:lvl4pPr marL="1371600" algn="l" defTabSz="914400" rtl="0" eaLnBrk="1" latinLnBrk="0" hangingPunct="1">
-              <a:defRPr sz="1800" kern="1200">
-                <a:solidFill>
-                  <a:schemeClr val="tx1"/>
-                </a:solidFill>
-                <a:latin typeface="+mn-lt"/>
-                <a:ea typeface="+mn-ea"/>
-                <a:cs typeface="+mn-cs"/>
-              </a:defRPr>
-            </a:lvl4pPr>
-            <a:lvl5pPr marL="1828800" algn="l" defTabSz="914400" rtl="0" eaLnBrk="1" latinLnBrk="0" hangingPunct="1">
-              <a:defRPr sz="1800" kern="1200">
-                <a:solidFill>
-                  <a:schemeClr val="tx1"/>
-                </a:solidFill>
-                <a:latin typeface="+mn-lt"/>
-                <a:ea typeface="+mn-ea"/>
-                <a:cs typeface="+mn-cs"/>
-              </a:defRPr>
-            </a:lvl5pPr>
-            <a:lvl6pPr marL="2286000" algn="l" defTabSz="914400" rtl="0" eaLnBrk="1" latinLnBrk="0" hangingPunct="1">
-              <a:defRPr sz="1800" kern="1200">
-                <a:solidFill>
-                  <a:schemeClr val="tx1"/>
-                </a:solidFill>
-                <a:latin typeface="+mn-lt"/>
-                <a:ea typeface="+mn-ea"/>
-                <a:cs typeface="+mn-cs"/>
-              </a:defRPr>
-            </a:lvl6pPr>
-            <a:lvl7pPr marL="2743200" algn="l" defTabSz="914400" rtl="0" eaLnBrk="1" latinLnBrk="0" hangingPunct="1">
-              <a:defRPr sz="1800" kern="1200">
-                <a:solidFill>
-                  <a:schemeClr val="tx1"/>
-                </a:solidFill>
-                <a:latin typeface="+mn-lt"/>
-                <a:ea typeface="+mn-ea"/>
-                <a:cs typeface="+mn-cs"/>
-              </a:defRPr>
-            </a:lvl7pPr>
-            <a:lvl8pPr marL="3200400" algn="l" defTabSz="914400" rtl="0" eaLnBrk="1" latinLnBrk="0" hangingPunct="1">
-              <a:defRPr sz="1800" kern="1200">
-                <a:solidFill>
-                  <a:schemeClr val="tx1"/>
-                </a:solidFill>
-                <a:latin typeface="+mn-lt"/>
-                <a:ea typeface="+mn-ea"/>
-                <a:cs typeface="+mn-cs"/>
-              </a:defRPr>
-            </a:lvl8pPr>
-            <a:lvl9pPr marL="3657600" algn="l" defTabSz="914400" rtl="0" eaLnBrk="1" latinLnBrk="0" hangingPunct="1">
-              <a:defRPr sz="1800" kern="1200">
-                <a:solidFill>
-                  <a:schemeClr val="tx1"/>
-                </a:solidFill>
-                <a:latin typeface="+mn-lt"/>
-                <a:ea typeface="+mn-ea"/>
-                <a:cs typeface="+mn-cs"/>
-              </a:defRPr>
-            </a:lvl9pPr>
-          </a:lstStyle>
-          <a:p>
-            <a:r>
-              <a:rPr lang="es-CO" sz="2000" dirty="0">
-                <a:ea typeface="+mn-lt"/>
-                <a:cs typeface="+mn-lt"/>
-              </a:rPr>
-              <a:t>1- Listado de requisitos</a:t>
-            </a:r>
-            <a:endParaRPr lang="en-US" sz="2000" dirty="0">
-              <a:ea typeface="+mn-lt"/>
-              <a:cs typeface="+mn-lt"/>
-            </a:endParaRPr>
-          </a:p>
-          <a:p>
-            <a:r>
-              <a:rPr lang="es-CO" sz="2000" dirty="0">
-                <a:ea typeface="+mn-lt"/>
-                <a:cs typeface="+mn-lt"/>
-              </a:rPr>
-              <a:t>2- Diagramas estructurales de datos (casos de uso, MER, MR)</a:t>
-            </a:r>
-            <a:endParaRPr lang="en-US" sz="2000" dirty="0">
-              <a:ea typeface="+mn-lt"/>
-              <a:cs typeface="+mn-lt"/>
-            </a:endParaRPr>
-          </a:p>
-          <a:p>
-            <a:r>
-              <a:rPr lang="es-CO" sz="2000" dirty="0">
-                <a:ea typeface="+mn-lt"/>
-                <a:cs typeface="+mn-lt"/>
-              </a:rPr>
-              <a:t>3- Nuevo esquema de procesos con la solución implementada</a:t>
-            </a:r>
-            <a:endParaRPr lang="es-ES" dirty="0">
-              <a:ea typeface="+mn-lt"/>
-              <a:cs typeface="+mn-lt"/>
-            </a:endParaRPr>
-          </a:p>
-        </p:txBody>
-      </p:sp>
-      <p:pic>
-        <p:nvPicPr>
-          <p:cNvPr id="2" name="Imagen 1">
-            <a:extLst>
-              <a:ext uri="{FF2B5EF4-FFF2-40B4-BE49-F238E27FC236}">
-                <a16:creationId xmlns:a16="http://schemas.microsoft.com/office/drawing/2014/main" id="{172C9472-EC57-2BD0-3BFB-85E20CB0DB66}"/>
-              </a:ext>
-            </a:extLst>
-          </p:cNvPr>
-          <p:cNvPicPr>
-            <a:picLocks noChangeAspect="1"/>
-          </p:cNvPicPr>
-          <p:nvPr/>
-        </p:nvPicPr>
-        <p:blipFill>
-          <a:blip r:embed="rId4"/>
-          <a:stretch>
-            <a:fillRect/>
-          </a:stretch>
-        </p:blipFill>
-        <p:spPr>
-          <a:xfrm>
-            <a:off x="8865089" y="5125050"/>
-            <a:ext cx="2527916" cy="929561"/>
-          </a:xfrm>
-          <a:prstGeom prst="rect">
-            <a:avLst/>
-          </a:prstGeom>
-        </p:spPr>
-      </p:pic>
-    </p:spTree>
-    <p:extLst>
-      <p:ext uri="{BB962C8B-B14F-4D97-AF65-F5344CB8AC3E}">
-        <p14:creationId xmlns:p14="http://schemas.microsoft.com/office/powerpoint/2010/main" val="610365739"/>
-      </p:ext>
-    </p:extLst>
-  </p:cSld>
-  <p:clrMapOvr>
-    <a:masterClrMapping/>
-  </p:clrMapOvr>
-  <p:extLst>
-    <p:ext uri="{6950BFC3-D8DA-4A85-94F7-54DA5524770B}">
-      <p188:commentRel xmlns:p188="http://schemas.microsoft.com/office/powerpoint/2018/8/main" r:id="rId2"/>
-    </p:ext>
-  </p:extLst>
-</p:sld>
-</file>
-
-<file path=ppt/slides/slide11.xml><?xml version="1.0" encoding="utf-8"?>
-<p:sld xmlns:a="http://schemas.openxmlformats.org/drawingml/2006/main" xmlns:r="http://schemas.openxmlformats.org/officeDocument/2006/relationships" xmlns:p="http://schemas.openxmlformats.org/presentationml/2006/main">
-  <p:cSld>
     <p:spTree>
       <p:nvGrpSpPr>
         <p:cNvPr id="1" name=""/>
@@ -5467,7 +5039,7 @@
         </p:nvSpPr>
         <p:spPr>
           <a:xfrm>
-            <a:off x="4459705" y="1158252"/>
+            <a:off x="4482484" y="964393"/>
             <a:ext cx="5181600" cy="523220"/>
           </a:xfrm>
           <a:prstGeom prst="rect">
@@ -5535,7 +5107,13 @@
             </a:extLst>
           </p:cNvPr>
           <p:cNvGraphicFramePr/>
-          <p:nvPr/>
+          <p:nvPr>
+            <p:extLst>
+              <p:ext uri="{D42A27DB-BD31-4B8C-83A1-F6EECF244321}">
+                <p14:modId xmlns:p14="http://schemas.microsoft.com/office/powerpoint/2010/main" val="208811698"/>
+              </p:ext>
+            </p:extLst>
+          </p:nvPr>
         </p:nvGraphicFramePr>
         <p:xfrm>
           <a:off x="6660335" y="1899815"/>
@@ -5579,10 +5157,18 @@
                         <a:buNone/>
                       </a:pPr>
                       <a:r>
-                        <a:rPr lang="es-CO" dirty="0"/>
+                        <a:rPr lang="es-CO" dirty="0">
+                          <a:solidFill>
+                            <a:schemeClr val="bg1"/>
+                          </a:solidFill>
+                        </a:rPr>
                         <a:t>Requerimientos</a:t>
                       </a:r>
-                      <a:endParaRPr dirty="0"/>
+                      <a:endParaRPr dirty="0">
+                        <a:solidFill>
+                          <a:schemeClr val="bg1"/>
+                        </a:solidFill>
+                      </a:endParaRPr>
                     </a:p>
                   </a:txBody>
                   <a:tcPr marL="91425" marR="91425" marT="91425" marB="91425">
@@ -5642,10 +5228,18 @@
                         <a:buNone/>
                       </a:pPr>
                       <a:r>
-                        <a:rPr lang="es-CO"/>
+                        <a:rPr lang="es-CO" dirty="0">
+                          <a:solidFill>
+                            <a:schemeClr val="bg1"/>
+                          </a:solidFill>
+                        </a:rPr>
                         <a:t>Resultado</a:t>
                       </a:r>
-                      <a:endParaRPr/>
+                      <a:endParaRPr dirty="0">
+                        <a:solidFill>
+                          <a:schemeClr val="bg1"/>
+                        </a:solidFill>
+                      </a:endParaRPr>
                     </a:p>
                   </a:txBody>
                   <a:tcPr marL="91425" marR="91425" marT="91425" marB="91425">
@@ -6130,11 +5724,17 @@
             </a:extLst>
           </p:cNvPr>
           <p:cNvGraphicFramePr/>
-          <p:nvPr/>
+          <p:nvPr>
+            <p:extLst>
+              <p:ext uri="{D42A27DB-BD31-4B8C-83A1-F6EECF244321}">
+                <p14:modId xmlns:p14="http://schemas.microsoft.com/office/powerpoint/2010/main" val="995642236"/>
+              </p:ext>
+            </p:extLst>
+          </p:nvPr>
         </p:nvGraphicFramePr>
         <p:xfrm>
-          <a:off x="6761701" y="3946838"/>
-          <a:ext cx="4123367" cy="2199365"/>
+          <a:off x="6660335" y="4566423"/>
+          <a:ext cx="4123367" cy="2108552"/>
         </p:xfrm>
         <a:graphic>
           <a:graphicData uri="http://schemas.openxmlformats.org/drawingml/2006/table">
@@ -6158,7 +5758,7 @@
                   </a:extLst>
                 </a:gridCol>
               </a:tblGrid>
-              <a:tr h="539256">
+              <a:tr h="462722">
                 <a:tc>
                   <a:txBody>
                     <a:bodyPr/>
@@ -6307,7 +5907,7 @@
                   </a:ext>
                 </a:extLst>
               </a:tr>
-              <a:tr h="745769">
+              <a:tr h="639925">
                 <a:tc>
                   <a:txBody>
                     <a:bodyPr/>
@@ -6449,7 +6049,7 @@
                   </a:ext>
                 </a:extLst>
               </a:tr>
-              <a:tr h="430989">
+              <a:tr h="392286">
                 <a:tc>
                   <a:txBody>
                     <a:bodyPr/>
@@ -6591,7 +6191,7 @@
                   </a:ext>
                 </a:extLst>
               </a:tr>
-              <a:tr h="430989">
+              <a:tr h="392286">
                 <a:tc>
                   <a:txBody>
                     <a:bodyPr/>
@@ -6738,6 +6338,89 @@
           </a:graphicData>
         </a:graphic>
       </p:graphicFrame>
+      <p:sp>
+        <p:nvSpPr>
+          <p:cNvPr id="9" name="Título 1">
+            <a:extLst>
+              <a:ext uri="{FF2B5EF4-FFF2-40B4-BE49-F238E27FC236}">
+                <a16:creationId xmlns:a16="http://schemas.microsoft.com/office/drawing/2014/main" id="{A461F2B3-944B-239B-05E1-D89E268CFB4E}"/>
+              </a:ext>
+            </a:extLst>
+          </p:cNvPr>
+          <p:cNvSpPr txBox="1">
+            <a:spLocks/>
+          </p:cNvSpPr>
+          <p:nvPr/>
+        </p:nvSpPr>
+        <p:spPr>
+          <a:xfrm>
+            <a:off x="6761701" y="3824860"/>
+            <a:ext cx="9815809" cy="741563"/>
+          </a:xfrm>
+          <a:prstGeom prst="rect">
+            <a:avLst/>
+          </a:prstGeom>
+          <a:ln>
+            <a:noFill/>
+          </a:ln>
+        </p:spPr>
+        <p:txBody>
+          <a:bodyPr/>
+          <a:lstStyle>
+            <a:lvl1pPr algn="l" defTabSz="914400" rtl="0" eaLnBrk="1" latinLnBrk="0" hangingPunct="1">
+              <a:lnSpc>
+                <a:spcPct val="90000"/>
+              </a:lnSpc>
+              <a:spcBef>
+                <a:spcPct val="0"/>
+              </a:spcBef>
+              <a:buNone/>
+              <a:defRPr sz="4400" kern="1200">
+                <a:solidFill>
+                  <a:schemeClr val="tx1"/>
+                </a:solidFill>
+                <a:latin typeface="+mj-lt"/>
+                <a:ea typeface="+mj-ea"/>
+                <a:cs typeface="+mj-cs"/>
+              </a:defRPr>
+            </a:lvl1pPr>
+          </a:lstStyle>
+          <a:p>
+            <a:pPr marL="0" marR="0" lvl="0" indent="0" algn="l" defTabSz="914400" rtl="0" eaLnBrk="1" fontAlgn="auto" latinLnBrk="0" hangingPunct="1">
+              <a:lnSpc>
+                <a:spcPct val="90000"/>
+              </a:lnSpc>
+              <a:spcBef>
+                <a:spcPct val="0"/>
+              </a:spcBef>
+              <a:spcAft>
+                <a:spcPts val="0"/>
+              </a:spcAft>
+              <a:buClrTx/>
+              <a:buSzTx/>
+              <a:buFontTx/>
+              <a:buNone/>
+              <a:tabLst/>
+              <a:defRPr/>
+            </a:pPr>
+            <a:r>
+              <a:rPr lang="es-ES" sz="3600" b="1" dirty="0">
+                <a:latin typeface="WORK SANS BOLD ROMAN" pitchFamily="2" charset="77"/>
+              </a:rPr>
+              <a:t>Tablas</a:t>
+            </a:r>
+            <a:endParaRPr kumimoji="0" lang="es-CO" sz="3600" b="1" u="none" strike="noStrike" kern="1200" cap="none" spc="0" normalizeH="0" baseline="0" noProof="0" dirty="0">
+              <a:ln>
+                <a:noFill/>
+              </a:ln>
+              <a:effectLst/>
+              <a:uLnTx/>
+              <a:uFillTx/>
+              <a:latin typeface="WORK SANS BOLD ROMAN" pitchFamily="2" charset="77"/>
+            </a:endParaRPr>
+          </a:p>
+        </p:txBody>
+      </p:sp>
     </p:spTree>
     <p:extLst>
       <p:ext uri="{BB962C8B-B14F-4D97-AF65-F5344CB8AC3E}">
@@ -6756,7 +6439,7 @@
 </p:sld>
 </file>
 
-<file path=ppt/slides/slide12.xml><?xml version="1.0" encoding="utf-8"?>
+<file path=ppt/slides/slide11.xml><?xml version="1.0" encoding="utf-8"?>
 <p:sld xmlns:a="http://schemas.openxmlformats.org/drawingml/2006/main" xmlns:r="http://schemas.openxmlformats.org/officeDocument/2006/relationships" xmlns:p="http://schemas.openxmlformats.org/presentationml/2006/main">
   <p:cSld>
     <p:spTree>
@@ -6930,7 +6613,7 @@
         </p:nvSpPr>
         <p:spPr>
           <a:xfrm>
-            <a:off x="4002572" y="1098646"/>
+            <a:off x="4360381" y="1169321"/>
             <a:ext cx="5181600" cy="523220"/>
           </a:xfrm>
           <a:prstGeom prst="rect">
@@ -6946,7 +6629,7 @@
           <a:p>
             <a:r>
               <a:rPr lang="es-CO" sz="2800" dirty="0"/>
-              <a:t>Tablas mas transaccional</a:t>
+              <a:t>Tabla mas transaccional</a:t>
             </a:r>
           </a:p>
         </p:txBody>
@@ -7029,7 +6712,7 @@
 </p:sld>
 </file>
 
-<file path=ppt/slides/slide13.xml><?xml version="1.0" encoding="utf-8"?>
+<file path=ppt/slides/slide12.xml><?xml version="1.0" encoding="utf-8"?>
 <p:sld xmlns:a="http://schemas.openxmlformats.org/drawingml/2006/main" xmlns:r="http://schemas.openxmlformats.org/officeDocument/2006/relationships" xmlns:p="http://schemas.openxmlformats.org/presentationml/2006/main">
   <p:cSld>
     <p:spTree>
@@ -7302,7 +6985,7 @@
 </p:sld>
 </file>
 
-<file path=ppt/slides/slide14.xml><?xml version="1.0" encoding="utf-8"?>
+<file path=ppt/slides/slide13.xml><?xml version="1.0" encoding="utf-8"?>
 <p:sld xmlns:a="http://schemas.openxmlformats.org/drawingml/2006/main" xmlns:r="http://schemas.openxmlformats.org/officeDocument/2006/relationships" xmlns:p="http://schemas.openxmlformats.org/presentationml/2006/main">
   <p:cSld>
     <p:spTree>
@@ -7796,7 +7479,7 @@
 </p:sld>
 </file>
 
-<file path=ppt/slides/slide15.xml><?xml version="1.0" encoding="utf-8"?>
+<file path=ppt/slides/slide14.xml><?xml version="1.0" encoding="utf-8"?>
 <p:sld xmlns:a="http://schemas.openxmlformats.org/drawingml/2006/main" xmlns:r="http://schemas.openxmlformats.org/officeDocument/2006/relationships" xmlns:p="http://schemas.openxmlformats.org/presentationml/2006/main">
   <p:cSld>
     <p:spTree>
@@ -8154,418 +7837,7 @@
 </p:sld>
 </file>
 
-<file path=ppt/slides/slide16.xml><?xml version="1.0" encoding="utf-8"?>
-<p:sld xmlns:a="http://schemas.openxmlformats.org/drawingml/2006/main" xmlns:r="http://schemas.openxmlformats.org/officeDocument/2006/relationships" xmlns:p="http://schemas.openxmlformats.org/presentationml/2006/main">
-  <p:cSld>
-    <p:bg>
-      <p:bgPr>
-        <a:blipFill dpi="0" rotWithShape="1">
-          <a:blip r:embed="rId2">
-            <a:lum/>
-          </a:blip>
-          <a:srcRect/>
-          <a:stretch>
-            <a:fillRect/>
-          </a:stretch>
-        </a:blipFill>
-        <a:effectLst/>
-      </p:bgPr>
-    </p:bg>
-    <p:spTree>
-      <p:nvGrpSpPr>
-        <p:cNvPr id="1" name=""/>
-        <p:cNvGrpSpPr/>
-        <p:nvPr/>
-      </p:nvGrpSpPr>
-      <p:grpSpPr>
-        <a:xfrm>
-          <a:off x="0" y="0"/>
-          <a:ext cx="0" cy="0"/>
-          <a:chOff x="0" y="0"/>
-          <a:chExt cx="0" cy="0"/>
-        </a:xfrm>
-      </p:grpSpPr>
-      <p:sp>
-        <p:nvSpPr>
-          <p:cNvPr id="3" name="Título 1">
-            <a:extLst>
-              <a:ext uri="{FF2B5EF4-FFF2-40B4-BE49-F238E27FC236}">
-                <a16:creationId xmlns:a16="http://schemas.microsoft.com/office/drawing/2014/main" id="{BB6F714C-A6B0-54AE-507A-D0700714D94B}"/>
-              </a:ext>
-            </a:extLst>
-          </p:cNvPr>
-          <p:cNvSpPr txBox="1">
-            <a:spLocks/>
-          </p:cNvSpPr>
-          <p:nvPr/>
-        </p:nvSpPr>
-        <p:spPr>
-          <a:xfrm>
-            <a:off x="456236" y="416690"/>
-            <a:ext cx="9815809" cy="527874"/>
-          </a:xfrm>
-          <a:prstGeom prst="rect">
-            <a:avLst/>
-          </a:prstGeom>
-        </p:spPr>
-        <p:txBody>
-          <a:bodyPr/>
-          <a:lstStyle>
-            <a:lvl1pPr algn="l" defTabSz="914400" rtl="0" eaLnBrk="1" latinLnBrk="0" hangingPunct="1">
-              <a:lnSpc>
-                <a:spcPct val="90000"/>
-              </a:lnSpc>
-              <a:spcBef>
-                <a:spcPct val="0"/>
-              </a:spcBef>
-              <a:buNone/>
-              <a:defRPr sz="4400" kern="1200">
-                <a:solidFill>
-                  <a:schemeClr val="tx1"/>
-                </a:solidFill>
-                <a:latin typeface="+mj-lt"/>
-                <a:ea typeface="+mj-ea"/>
-                <a:cs typeface="+mj-cs"/>
-              </a:defRPr>
-            </a:lvl1pPr>
-          </a:lstStyle>
-          <a:p>
-            <a:pPr marL="0" marR="0" lvl="0" indent="0" algn="l" defTabSz="914400" rtl="0" eaLnBrk="1" fontAlgn="auto" latinLnBrk="0" hangingPunct="1">
-              <a:lnSpc>
-                <a:spcPct val="90000"/>
-              </a:lnSpc>
-              <a:spcBef>
-                <a:spcPct val="0"/>
-              </a:spcBef>
-              <a:spcAft>
-                <a:spcPts val="0"/>
-              </a:spcAft>
-              <a:buClrTx/>
-              <a:buSzTx/>
-              <a:buFontTx/>
-              <a:buNone/>
-              <a:tabLst/>
-              <a:defRPr/>
-            </a:pPr>
-            <a:r>
-              <a:rPr kumimoji="0" lang="es-CO" sz="3600" b="1" u="none" strike="noStrike" kern="1200" cap="none" spc="0" normalizeH="0" baseline="0" noProof="0" dirty="0">
-                <a:ln>
-                  <a:noFill/>
-                </a:ln>
-                <a:solidFill>
-                  <a:prstClr val="white"/>
-                </a:solidFill>
-                <a:effectLst/>
-                <a:uLnTx/>
-                <a:uFillTx/>
-                <a:latin typeface="WORK SANS BOLD ROMAN" pitchFamily="2" charset="77"/>
-              </a:rPr>
-              <a:t>Cronograma</a:t>
-            </a:r>
-          </a:p>
-        </p:txBody>
-      </p:sp>
-      <p:pic>
-        <p:nvPicPr>
-          <p:cNvPr id="2" name="Picture 1" descr="A white and black box with black text&#10;&#10;AI-generated content may be incorrect.">
-            <a:extLst>
-              <a:ext uri="{FF2B5EF4-FFF2-40B4-BE49-F238E27FC236}">
-                <a16:creationId xmlns:a16="http://schemas.microsoft.com/office/drawing/2014/main" id="{6F7079A7-0924-504D-AC9E-700C66EF43B8}"/>
-              </a:ext>
-            </a:extLst>
-          </p:cNvPr>
-          <p:cNvPicPr>
-            <a:picLocks noChangeAspect="1"/>
-          </p:cNvPicPr>
-          <p:nvPr/>
-        </p:nvPicPr>
-        <p:blipFill>
-          <a:blip r:embed="rId3"/>
-          <a:srcRect r="354" b="4469"/>
-          <a:stretch>
-            <a:fillRect/>
-          </a:stretch>
-        </p:blipFill>
-        <p:spPr>
-          <a:xfrm>
-            <a:off x="330679" y="1527233"/>
-            <a:ext cx="11717558" cy="4752092"/>
-          </a:xfrm>
-          <a:prstGeom prst="rect">
-            <a:avLst/>
-          </a:prstGeom>
-        </p:spPr>
-      </p:pic>
-      <p:pic>
-        <p:nvPicPr>
-          <p:cNvPr id="4" name="Imagen 3">
-            <a:extLst>
-              <a:ext uri="{FF2B5EF4-FFF2-40B4-BE49-F238E27FC236}">
-                <a16:creationId xmlns:a16="http://schemas.microsoft.com/office/drawing/2014/main" id="{17FA3F96-CEED-5553-F361-6C0625A61313}"/>
-              </a:ext>
-            </a:extLst>
-          </p:cNvPr>
-          <p:cNvPicPr>
-            <a:picLocks noChangeAspect="1"/>
-          </p:cNvPicPr>
-          <p:nvPr/>
-        </p:nvPicPr>
-        <p:blipFill>
-          <a:blip r:embed="rId4"/>
-          <a:stretch>
-            <a:fillRect/>
-          </a:stretch>
-        </p:blipFill>
-        <p:spPr>
-          <a:xfrm>
-            <a:off x="8742947" y="215846"/>
-            <a:ext cx="2527916" cy="929561"/>
-          </a:xfrm>
-          <a:prstGeom prst="rect">
-            <a:avLst/>
-          </a:prstGeom>
-        </p:spPr>
-      </p:pic>
-    </p:spTree>
-    <p:extLst>
-      <p:ext uri="{BB962C8B-B14F-4D97-AF65-F5344CB8AC3E}">
-        <p14:creationId xmlns:p14="http://schemas.microsoft.com/office/powerpoint/2010/main" val="2269292441"/>
-      </p:ext>
-    </p:extLst>
-  </p:cSld>
-  <p:clrMapOvr>
-    <a:masterClrMapping/>
-  </p:clrMapOvr>
-</p:sld>
-</file>
-
-<file path=ppt/slides/slide17.xml><?xml version="1.0" encoding="utf-8"?>
-<p:sld xmlns:a="http://schemas.openxmlformats.org/drawingml/2006/main" xmlns:r="http://schemas.openxmlformats.org/officeDocument/2006/relationships" xmlns:p="http://schemas.openxmlformats.org/presentationml/2006/main">
-  <p:cSld>
-    <p:spTree>
-      <p:nvGrpSpPr>
-        <p:cNvPr id="1" name=""/>
-        <p:cNvGrpSpPr/>
-        <p:nvPr/>
-      </p:nvGrpSpPr>
-      <p:grpSpPr>
-        <a:xfrm>
-          <a:off x="0" y="0"/>
-          <a:ext cx="0" cy="0"/>
-          <a:chOff x="0" y="0"/>
-          <a:chExt cx="0" cy="0"/>
-        </a:xfrm>
-      </p:grpSpPr>
-      <p:sp>
-        <p:nvSpPr>
-          <p:cNvPr id="3" name="Título 1">
-            <a:extLst>
-              <a:ext uri="{FF2B5EF4-FFF2-40B4-BE49-F238E27FC236}">
-                <a16:creationId xmlns:a16="http://schemas.microsoft.com/office/drawing/2014/main" id="{BB6F714C-A6B0-54AE-507A-D0700714D94B}"/>
-              </a:ext>
-            </a:extLst>
-          </p:cNvPr>
-          <p:cNvSpPr txBox="1">
-            <a:spLocks/>
-          </p:cNvSpPr>
-          <p:nvPr/>
-        </p:nvSpPr>
-        <p:spPr>
-          <a:xfrm>
-            <a:off x="456236" y="416690"/>
-            <a:ext cx="9815809" cy="527874"/>
-          </a:xfrm>
-          <a:prstGeom prst="rect">
-            <a:avLst/>
-          </a:prstGeom>
-        </p:spPr>
-        <p:txBody>
-          <a:bodyPr lIns="91440" tIns="45720" rIns="91440" bIns="45720" anchor="t"/>
-          <a:lstStyle>
-            <a:lvl1pPr algn="l" defTabSz="914400" rtl="0" eaLnBrk="1" latinLnBrk="0" hangingPunct="1">
-              <a:lnSpc>
-                <a:spcPct val="90000"/>
-              </a:lnSpc>
-              <a:spcBef>
-                <a:spcPct val="0"/>
-              </a:spcBef>
-              <a:buNone/>
-              <a:defRPr sz="4400" kern="1200">
-                <a:solidFill>
-                  <a:schemeClr val="tx1"/>
-                </a:solidFill>
-                <a:latin typeface="+mj-lt"/>
-                <a:ea typeface="+mj-ea"/>
-                <a:cs typeface="+mj-cs"/>
-              </a:defRPr>
-            </a:lvl1pPr>
-          </a:lstStyle>
-          <a:p>
-            <a:pPr marL="0" marR="0" lvl="0" indent="0" algn="l" defTabSz="914400" rtl="0" eaLnBrk="1" fontAlgn="auto" latinLnBrk="0" hangingPunct="1">
-              <a:lnSpc>
-                <a:spcPct val="90000"/>
-              </a:lnSpc>
-              <a:spcBef>
-                <a:spcPct val="0"/>
-              </a:spcBef>
-              <a:spcAft>
-                <a:spcPts val="0"/>
-              </a:spcAft>
-              <a:buClrTx/>
-              <a:buSzTx/>
-              <a:buFontTx/>
-              <a:buNone/>
-              <a:tabLst/>
-              <a:defRPr/>
-            </a:pPr>
-            <a:r>
-              <a:rPr kumimoji="0" lang="es-CO" sz="3600" b="1" u="none" strike="noStrike" kern="1200" cap="none" spc="0" normalizeH="0" baseline="0" noProof="0" dirty="0">
-                <a:ln>
-                  <a:noFill/>
-                </a:ln>
-                <a:effectLst/>
-                <a:uLnTx/>
-                <a:uFillTx/>
-                <a:latin typeface="WORK SANS BOLD ROMAN"/>
-              </a:rPr>
-              <a:t>Avances</a:t>
-            </a:r>
-          </a:p>
-        </p:txBody>
-      </p:sp>
-      <p:sp>
-        <p:nvSpPr>
-          <p:cNvPr id="2" name="TextBox 1">
-            <a:extLst>
-              <a:ext uri="{FF2B5EF4-FFF2-40B4-BE49-F238E27FC236}">
-                <a16:creationId xmlns:a16="http://schemas.microsoft.com/office/drawing/2014/main" id="{EC6EDBC5-9719-5298-F46B-FFD61D7493B8}"/>
-              </a:ext>
-            </a:extLst>
-          </p:cNvPr>
-          <p:cNvSpPr txBox="1"/>
-          <p:nvPr/>
-        </p:nvSpPr>
-        <p:spPr>
-          <a:xfrm>
-            <a:off x="6853708" y="2782669"/>
-            <a:ext cx="2020328" cy="646331"/>
-          </a:xfrm>
-          <a:prstGeom prst="rect">
-            <a:avLst/>
-          </a:prstGeom>
-          <a:noFill/>
-        </p:spPr>
-        <p:txBody>
-          <a:bodyPr rot="0" spcFirstLastPara="0" vertOverflow="overflow" horzOverflow="overflow" vert="horz" wrap="square" lIns="91440" tIns="45720" rIns="91440" bIns="45720" numCol="1" spcCol="0" rtlCol="0" fromWordArt="0" anchor="t" anchorCtr="0" forceAA="0" compatLnSpc="1">
-            <a:prstTxWarp prst="textNoShape">
-              <a:avLst/>
-            </a:prstTxWarp>
-            <a:spAutoFit/>
-          </a:bodyPr>
-          <a:lstStyle/>
-          <a:p>
-            <a:r>
-              <a:rPr lang="en-US" sz="3600" dirty="0">
-                <a:ea typeface="Calibri"/>
-                <a:cs typeface="Calibri"/>
-                <a:hlinkClick r:id="rId2"/>
-              </a:rPr>
-              <a:t>Click aqui</a:t>
-            </a:r>
-          </a:p>
-        </p:txBody>
-      </p:sp>
-      <p:pic>
-        <p:nvPicPr>
-          <p:cNvPr id="3074" name="Picture 2" descr="GitHub Logo and symbol, meaning, history, PNG, brand">
-            <a:extLst>
-              <a:ext uri="{FF2B5EF4-FFF2-40B4-BE49-F238E27FC236}">
-                <a16:creationId xmlns:a16="http://schemas.microsoft.com/office/drawing/2014/main" id="{50AFD77A-0689-42F1-6076-607F21520450}"/>
-              </a:ext>
-            </a:extLst>
-          </p:cNvPr>
-          <p:cNvPicPr>
-            <a:picLocks noChangeAspect="1" noChangeArrowheads="1"/>
-          </p:cNvPicPr>
-          <p:nvPr/>
-        </p:nvPicPr>
-        <p:blipFill>
-          <a:blip r:embed="rId3">
-            <a:extLst>
-              <a:ext uri="{28A0092B-C50C-407E-A947-70E740481C1C}">
-                <a14:useLocalDpi xmlns:a14="http://schemas.microsoft.com/office/drawing/2010/main" val="0"/>
-              </a:ext>
-            </a:extLst>
-          </a:blip>
-          <a:srcRect/>
-          <a:stretch>
-            <a:fillRect/>
-          </a:stretch>
-        </p:blipFill>
-        <p:spPr bwMode="auto">
-          <a:xfrm>
-            <a:off x="657532" y="1454332"/>
-            <a:ext cx="6277913" cy="3531326"/>
-          </a:xfrm>
-          <a:prstGeom prst="rect">
-            <a:avLst/>
-          </a:prstGeom>
-          <a:noFill/>
-          <a:extLst>
-            <a:ext uri="{909E8E84-426E-40DD-AFC4-6F175D3DCCD1}">
-              <a14:hiddenFill xmlns:a14="http://schemas.microsoft.com/office/drawing/2010/main">
-                <a:solidFill>
-                  <a:srgbClr val="FFFFFF"/>
-                </a:solidFill>
-              </a14:hiddenFill>
-            </a:ext>
-          </a:extLst>
-        </p:spPr>
-      </p:pic>
-      <p:pic>
-        <p:nvPicPr>
-          <p:cNvPr id="5" name="Imagen 4">
-            <a:extLst>
-              <a:ext uri="{FF2B5EF4-FFF2-40B4-BE49-F238E27FC236}">
-                <a16:creationId xmlns:a16="http://schemas.microsoft.com/office/drawing/2014/main" id="{D7398FCE-9ECE-CDD2-B0FD-7945DAB66ADA}"/>
-              </a:ext>
-            </a:extLst>
-          </p:cNvPr>
-          <p:cNvPicPr>
-            <a:picLocks noChangeAspect="1"/>
-          </p:cNvPicPr>
-          <p:nvPr/>
-        </p:nvPicPr>
-        <p:blipFill>
-          <a:blip r:embed="rId4"/>
-          <a:stretch>
-            <a:fillRect/>
-          </a:stretch>
-        </p:blipFill>
-        <p:spPr>
-          <a:xfrm>
-            <a:off x="9352547" y="5458146"/>
-            <a:ext cx="2527916" cy="929561"/>
-          </a:xfrm>
-          <a:prstGeom prst="rect">
-            <a:avLst/>
-          </a:prstGeom>
-        </p:spPr>
-      </p:pic>
-    </p:spTree>
-    <p:extLst>
-      <p:ext uri="{BB962C8B-B14F-4D97-AF65-F5344CB8AC3E}">
-        <p14:creationId xmlns:p14="http://schemas.microsoft.com/office/powerpoint/2010/main" val="3230526153"/>
-      </p:ext>
-    </p:extLst>
-  </p:cSld>
-  <p:clrMapOvr>
-    <a:masterClrMapping/>
-  </p:clrMapOvr>
-</p:sld>
-</file>
-
-<file path=ppt/slides/slide18.xml><?xml version="1.0" encoding="utf-8"?>
+<file path=ppt/slides/slide15.xml><?xml version="1.0" encoding="utf-8"?>
 <p:sld xmlns:a="http://schemas.openxmlformats.org/drawingml/2006/main" xmlns:r="http://schemas.openxmlformats.org/officeDocument/2006/relationships" xmlns:p="http://schemas.openxmlformats.org/presentationml/2006/main">
   <p:cSld>
     <p:bg>
@@ -9013,7 +8285,7 @@
                 <a:ea typeface="+mn-lt"/>
                 <a:cs typeface="+mn-lt"/>
               </a:rPr>
-              <a:t>La escasa demanda de aplicaciones de reservas, junto con la limitada disponibilidad de información sobre los establecimientos que las utilizan, creando una escasa información al usuario obstaculiza una gestión eficiente y oportuna de las reservas. Asimismo, numerosos restaurantes requieren estrategias de visibilidad y promoción que les permitan posicionarse adecuadamente en el mercado.</a:t>
+              <a:t>La escasa oferta de aplicaciones de reservas, junto con la limitada disponibilidad de información sobre los establecimientos que las utilizan, creando una escasa información al usuario obstaculizando una gestión eficiente y oportuna de las reservas. Asimismo, numerosos restaurantes requieren estrategias de visibilidad y promoción que les permitan posicionarse adecuadamente en el mercado.</a:t>
             </a:r>
             <a:endParaRPr lang="en-US" dirty="0">
               <a:ea typeface="+mn-lt"/>
@@ -10389,14 +9661,12 @@
           <a:p>
             <a:r>
               <a:rPr lang="es-CO" sz="2400" dirty="0">
-                <a:latin typeface="Times New Roman"/>
                 <a:ea typeface="+mn-lt"/>
                 <a:cs typeface="+mn-lt"/>
               </a:rPr>
-              <a:t>Reservify es un proyecto enfocado en automatizar las reservas de restaurantes. La idea es mejorarle la expericienta al usuario al hacer reservas de manera rápida, como reuniones o citas, desde la comodidad de su casa, y que el empleado simplemente revise en la página las reservas que tiene ese día.</a:t>
+              <a:t>Reservify es un proyecto enfocado en facilitar el flujo las reservas de restaurantes. La idea es mejorar la expericienta al usuario al hacer reservas de manera rápida, como reuniones o citas, desde la comodidad de su casa, y que el empleado simplemente revise en la página las reservas las cuales se han realizado a lo largo del día.</a:t>
             </a:r>
             <a:endParaRPr lang="en-US" dirty="0">
-              <a:latin typeface="Times New Roman"/>
               <a:ea typeface="+mn-lt"/>
               <a:cs typeface="+mn-lt"/>
             </a:endParaRPr>
@@ -10407,11 +9677,10 @@
             </a:pPr>
             <a:r>
               <a:rPr lang="es-CO" sz="2400" dirty="0">
-                <a:latin typeface="Times New Roman"/>
                 <a:ea typeface="+mn-lt"/>
                 <a:cs typeface="+mn-lt"/>
               </a:rPr>
-              <a:t>Optimización del flujo de clientes al restaurante.</a:t>
+              <a:t>Optimización del flujo de clientes en el restaurante.</a:t>
             </a:r>
           </a:p>
           <a:p>
@@ -10420,11 +9689,10 @@
             </a:pPr>
             <a:r>
               <a:rPr lang="es-CO" sz="2400" dirty="0">
-                <a:latin typeface="Times New Roman"/>
                 <a:ea typeface="+mn-lt"/>
                 <a:cs typeface="+mn-lt"/>
               </a:rPr>
-              <a:t>Facilitarle la búsqueda al usuario acerca de los restaurantes más cercanos y/o encontrar un restaurante en específico.</a:t>
+              <a:t>Facilitarle la búsqueda al usuario sobre los restaurantes más cercanos y/o encontrar un restaurante en específico.</a:t>
             </a:r>
           </a:p>
           <a:p>
@@ -10433,11 +9701,24 @@
             </a:pPr>
             <a:r>
               <a:rPr lang="es-CO" sz="2400" dirty="0">
-                <a:latin typeface="Times New Roman"/>
                 <a:ea typeface="+mn-lt"/>
                 <a:cs typeface="+mn-lt"/>
               </a:rPr>
-              <a:t>Brindarle al cliente una experiencia más amena usando la aplicación.</a:t>
+              <a:t>Brindarle al cliente una experiencia más amena a la hora de utilizar la </a:t>
+            </a:r>
+            <a:r>
+              <a:rPr lang="es-CO" sz="2400" dirty="0" err="1">
+                <a:ea typeface="+mn-lt"/>
+                <a:cs typeface="+mn-lt"/>
+              </a:rPr>
+              <a:t>aplicacion</a:t>
+            </a:r>
+            <a:r>
+              <a:rPr lang="es-CO" sz="2400" dirty="0">
+                <a:ea typeface="+mn-lt"/>
+                <a:cs typeface="+mn-lt"/>
+              </a:rPr>
+              <a:t>.</a:t>
             </a:r>
           </a:p>
           <a:p>

</xml_diff>